<commit_message>
Refactor UI with SVG and custom CSS for reliable layout: huge record button, accurate tuner arc with triangles, pendulum rod, inline plus minus
</commit_message>
<xml_diff>
--- a/image.pptx
+++ b/image.pptx
@@ -3342,6 +3342,1101 @@
           <a:chExt cx="0" cy="0"/>
         </a:xfrm>
       </p:grpSpPr>
+      <p:sp>
+        <p:nvSpPr>
+          <p:cNvPr id="4" name="Rectangle: Rounded Corners 3">
+            <a:extLst>
+              <a:ext uri="{FF2B5EF4-FFF2-40B4-BE49-F238E27FC236}">
+                <a16:creationId xmlns:a16="http://schemas.microsoft.com/office/drawing/2014/main" id="{EAC72A5B-25A7-5B64-A9DD-707DB6EF0B3C}"/>
+              </a:ext>
+            </a:extLst>
+          </p:cNvPr>
+          <p:cNvSpPr/>
+          <p:nvPr/>
+        </p:nvSpPr>
+        <p:spPr>
+          <a:xfrm>
+            <a:off x="1005840" y="2465647"/>
+            <a:ext cx="2624328" cy="1252728"/>
+          </a:xfrm>
+          <a:prstGeom prst="roundRect">
+            <a:avLst/>
+          </a:prstGeom>
+        </p:spPr>
+        <p:style>
+          <a:lnRef idx="2">
+            <a:schemeClr val="dk1"/>
+          </a:lnRef>
+          <a:fillRef idx="1">
+            <a:schemeClr val="lt1"/>
+          </a:fillRef>
+          <a:effectRef idx="0">
+            <a:schemeClr val="dk1"/>
+          </a:effectRef>
+          <a:fontRef idx="minor">
+            <a:schemeClr val="dk1"/>
+          </a:fontRef>
+        </p:style>
+        <p:txBody>
+          <a:bodyPr rtlCol="0" anchor="ctr"/>
+          <a:lstStyle/>
+          <a:p>
+            <a:pPr algn="ctr"/>
+            <a:endParaRPr kumimoji="1" lang="ja-JP" altLang="en-US"/>
+          </a:p>
+        </p:txBody>
+      </p:sp>
+      <p:sp>
+        <p:nvSpPr>
+          <p:cNvPr id="6" name="Arc 5">
+            <a:extLst>
+              <a:ext uri="{FF2B5EF4-FFF2-40B4-BE49-F238E27FC236}">
+                <a16:creationId xmlns:a16="http://schemas.microsoft.com/office/drawing/2014/main" id="{88715743-4C2A-2331-076D-416C81D0E4CF}"/>
+              </a:ext>
+            </a:extLst>
+          </p:cNvPr>
+          <p:cNvSpPr/>
+          <p:nvPr/>
+        </p:nvSpPr>
+        <p:spPr>
+          <a:xfrm rot="19084917">
+            <a:off x="9145" y="2922947"/>
+            <a:ext cx="4617720" cy="4617720"/>
+          </a:xfrm>
+          <a:prstGeom prst="arc">
+            <a:avLst>
+              <a:gd name="adj1" fmla="val 17155046"/>
+              <a:gd name="adj2" fmla="val 20321333"/>
+            </a:avLst>
+          </a:prstGeom>
+        </p:spPr>
+        <p:style>
+          <a:lnRef idx="2">
+            <a:schemeClr val="dk1"/>
+          </a:lnRef>
+          <a:fillRef idx="0">
+            <a:schemeClr val="dk1"/>
+          </a:fillRef>
+          <a:effectRef idx="1">
+            <a:schemeClr val="dk1"/>
+          </a:effectRef>
+          <a:fontRef idx="minor">
+            <a:schemeClr val="tx1"/>
+          </a:fontRef>
+        </p:style>
+        <p:txBody>
+          <a:bodyPr rtlCol="0" anchor="ctr"/>
+          <a:lstStyle/>
+          <a:p>
+            <a:pPr algn="ctr"/>
+            <a:endParaRPr kumimoji="1" lang="ja-JP" altLang="en-US"/>
+          </a:p>
+        </p:txBody>
+      </p:sp>
+      <p:sp>
+        <p:nvSpPr>
+          <p:cNvPr id="7" name="Rectangle: Rounded Corners 6">
+            <a:extLst>
+              <a:ext uri="{FF2B5EF4-FFF2-40B4-BE49-F238E27FC236}">
+                <a16:creationId xmlns:a16="http://schemas.microsoft.com/office/drawing/2014/main" id="{22334233-0F36-85C8-934D-1DF50C9AA95B}"/>
+              </a:ext>
+            </a:extLst>
+          </p:cNvPr>
+          <p:cNvSpPr/>
+          <p:nvPr/>
+        </p:nvSpPr>
+        <p:spPr>
+          <a:xfrm rot="21144168">
+            <a:off x="1772539" y="2626865"/>
+            <a:ext cx="73152" cy="237744"/>
+          </a:xfrm>
+          <a:prstGeom prst="roundRect">
+            <a:avLst/>
+          </a:prstGeom>
+        </p:spPr>
+        <p:style>
+          <a:lnRef idx="0">
+            <a:schemeClr val="accent2"/>
+          </a:lnRef>
+          <a:fillRef idx="3">
+            <a:schemeClr val="accent2"/>
+          </a:fillRef>
+          <a:effectRef idx="3">
+            <a:schemeClr val="accent2"/>
+          </a:effectRef>
+          <a:fontRef idx="minor">
+            <a:schemeClr val="lt1"/>
+          </a:fontRef>
+        </p:style>
+        <p:txBody>
+          <a:bodyPr rtlCol="0" anchor="ctr"/>
+          <a:lstStyle/>
+          <a:p>
+            <a:pPr algn="ctr"/>
+            <a:endParaRPr kumimoji="1" lang="ja-JP" altLang="en-US"/>
+          </a:p>
+        </p:txBody>
+      </p:sp>
+      <p:sp>
+        <p:nvSpPr>
+          <p:cNvPr id="8" name="TextBox 7">
+            <a:extLst>
+              <a:ext uri="{FF2B5EF4-FFF2-40B4-BE49-F238E27FC236}">
+                <a16:creationId xmlns:a16="http://schemas.microsoft.com/office/drawing/2014/main" id="{BFC3D6D3-705E-F27E-2D3A-F574A5AA3197}"/>
+              </a:ext>
+            </a:extLst>
+          </p:cNvPr>
+          <p:cNvSpPr txBox="1"/>
+          <p:nvPr/>
+        </p:nvSpPr>
+        <p:spPr>
+          <a:xfrm>
+            <a:off x="1990090" y="3132016"/>
+            <a:ext cx="746760" cy="584775"/>
+          </a:xfrm>
+          <a:prstGeom prst="rect">
+            <a:avLst/>
+          </a:prstGeom>
+          <a:noFill/>
+        </p:spPr>
+        <p:txBody>
+          <a:bodyPr wrap="square" rtlCol="0">
+            <a:spAutoFit/>
+          </a:bodyPr>
+          <a:lstStyle/>
+          <a:p>
+            <a:r>
+              <a:rPr kumimoji="1" lang="en-US" altLang="ja-JP" sz="3200" dirty="0">
+                <a:solidFill>
+                  <a:srgbClr val="FF0000"/>
+                </a:solidFill>
+              </a:rPr>
+              <a:t>C#</a:t>
+            </a:r>
+            <a:endParaRPr kumimoji="1" lang="ja-JP" altLang="en-US" sz="3200" dirty="0">
+              <a:solidFill>
+                <a:srgbClr val="FF0000"/>
+              </a:solidFill>
+            </a:endParaRPr>
+          </a:p>
+        </p:txBody>
+      </p:sp>
+      <p:sp>
+        <p:nvSpPr>
+          <p:cNvPr id="9" name="TextBox 8">
+            <a:extLst>
+              <a:ext uri="{FF2B5EF4-FFF2-40B4-BE49-F238E27FC236}">
+                <a16:creationId xmlns:a16="http://schemas.microsoft.com/office/drawing/2014/main" id="{70FE499B-A1F3-7870-9B32-8B012ADE3DE2}"/>
+              </a:ext>
+            </a:extLst>
+          </p:cNvPr>
+          <p:cNvSpPr txBox="1"/>
+          <p:nvPr/>
+        </p:nvSpPr>
+        <p:spPr>
+          <a:xfrm>
+            <a:off x="1005839" y="3765498"/>
+            <a:ext cx="5290186" cy="523220"/>
+          </a:xfrm>
+          <a:prstGeom prst="rect">
+            <a:avLst/>
+          </a:prstGeom>
+          <a:noFill/>
+        </p:spPr>
+        <p:txBody>
+          <a:bodyPr wrap="square" rtlCol="0">
+            <a:spAutoFit/>
+          </a:bodyPr>
+          <a:lstStyle/>
+          <a:p>
+            <a:r>
+              <a:rPr kumimoji="1" lang="en-US" altLang="ja-JP" sz="2800" dirty="0"/>
+              <a:t>440Hz</a:t>
+            </a:r>
+            <a:r>
+              <a:rPr kumimoji="1" lang="ja-JP" altLang="en-US" sz="2800" dirty="0"/>
+              <a:t>（ここは編集可能）</a:t>
+            </a:r>
+          </a:p>
+        </p:txBody>
+      </p:sp>
+      <p:sp>
+        <p:nvSpPr>
+          <p:cNvPr id="12" name="Rectangle: Rounded Corners 11">
+            <a:extLst>
+              <a:ext uri="{FF2B5EF4-FFF2-40B4-BE49-F238E27FC236}">
+                <a16:creationId xmlns:a16="http://schemas.microsoft.com/office/drawing/2014/main" id="{E6F188C8-0E4F-DC13-F288-66555971B676}"/>
+              </a:ext>
+            </a:extLst>
+          </p:cNvPr>
+          <p:cNvSpPr/>
+          <p:nvPr/>
+        </p:nvSpPr>
+        <p:spPr>
+          <a:xfrm>
+            <a:off x="2114550" y="4446467"/>
+            <a:ext cx="45719" cy="1266004"/>
+          </a:xfrm>
+          <a:prstGeom prst="roundRect">
+            <a:avLst/>
+          </a:prstGeom>
+        </p:spPr>
+        <p:style>
+          <a:lnRef idx="2">
+            <a:schemeClr val="accent2">
+              <a:shade val="15000"/>
+            </a:schemeClr>
+          </a:lnRef>
+          <a:fillRef idx="1">
+            <a:schemeClr val="accent2"/>
+          </a:fillRef>
+          <a:effectRef idx="0">
+            <a:schemeClr val="accent2"/>
+          </a:effectRef>
+          <a:fontRef idx="minor">
+            <a:schemeClr val="lt1"/>
+          </a:fontRef>
+        </p:style>
+        <p:txBody>
+          <a:bodyPr rtlCol="0" anchor="ctr"/>
+          <a:lstStyle/>
+          <a:p>
+            <a:pPr algn="ctr"/>
+            <a:endParaRPr kumimoji="1" lang="ja-JP" altLang="en-US"/>
+          </a:p>
+        </p:txBody>
+      </p:sp>
+      <p:sp>
+        <p:nvSpPr>
+          <p:cNvPr id="13" name="Rectangle: Rounded Corners 12">
+            <a:extLst>
+              <a:ext uri="{FF2B5EF4-FFF2-40B4-BE49-F238E27FC236}">
+                <a16:creationId xmlns:a16="http://schemas.microsoft.com/office/drawing/2014/main" id="{B58B6006-3464-A181-D165-4D596245FAB7}"/>
+              </a:ext>
+            </a:extLst>
+          </p:cNvPr>
+          <p:cNvSpPr/>
+          <p:nvPr/>
+        </p:nvSpPr>
+        <p:spPr>
+          <a:xfrm>
+            <a:off x="1990090" y="95635"/>
+            <a:ext cx="466725" cy="466725"/>
+          </a:xfrm>
+          <a:prstGeom prst="roundRect">
+            <a:avLst/>
+          </a:prstGeom>
+          <a:solidFill>
+            <a:srgbClr val="FF0000"/>
+          </a:solidFill>
+          <a:ln>
+            <a:noFill/>
+          </a:ln>
+        </p:spPr>
+        <p:style>
+          <a:lnRef idx="2">
+            <a:schemeClr val="accent1">
+              <a:shade val="15000"/>
+            </a:schemeClr>
+          </a:lnRef>
+          <a:fillRef idx="1">
+            <a:schemeClr val="accent1"/>
+          </a:fillRef>
+          <a:effectRef idx="0">
+            <a:schemeClr val="accent1"/>
+          </a:effectRef>
+          <a:fontRef idx="minor">
+            <a:schemeClr val="lt1"/>
+          </a:fontRef>
+        </p:style>
+        <p:txBody>
+          <a:bodyPr rtlCol="0" anchor="ctr"/>
+          <a:lstStyle/>
+          <a:p>
+            <a:pPr algn="ctr"/>
+            <a:endParaRPr kumimoji="1" lang="ja-JP" altLang="en-US"/>
+          </a:p>
+        </p:txBody>
+      </p:sp>
+      <p:sp>
+        <p:nvSpPr>
+          <p:cNvPr id="14" name="Oval 13">
+            <a:extLst>
+              <a:ext uri="{FF2B5EF4-FFF2-40B4-BE49-F238E27FC236}">
+                <a16:creationId xmlns:a16="http://schemas.microsoft.com/office/drawing/2014/main" id="{A509B625-E94B-E86A-0A28-E9199960BFAC}"/>
+              </a:ext>
+            </a:extLst>
+          </p:cNvPr>
+          <p:cNvSpPr/>
+          <p:nvPr/>
+        </p:nvSpPr>
+        <p:spPr>
+          <a:xfrm>
+            <a:off x="2142489" y="248034"/>
+            <a:ext cx="161925" cy="161925"/>
+          </a:xfrm>
+          <a:prstGeom prst="ellipse">
+            <a:avLst/>
+          </a:prstGeom>
+          <a:solidFill>
+            <a:srgbClr val="C00000"/>
+          </a:solidFill>
+          <a:ln>
+            <a:noFill/>
+          </a:ln>
+        </p:spPr>
+        <p:style>
+          <a:lnRef idx="2">
+            <a:schemeClr val="accent1">
+              <a:shade val="15000"/>
+            </a:schemeClr>
+          </a:lnRef>
+          <a:fillRef idx="1">
+            <a:schemeClr val="accent1"/>
+          </a:fillRef>
+          <a:effectRef idx="0">
+            <a:schemeClr val="accent1"/>
+          </a:effectRef>
+          <a:fontRef idx="minor">
+            <a:schemeClr val="lt1"/>
+          </a:fontRef>
+        </p:style>
+        <p:txBody>
+          <a:bodyPr rtlCol="0" anchor="ctr"/>
+          <a:lstStyle/>
+          <a:p>
+            <a:pPr algn="ctr"/>
+            <a:endParaRPr kumimoji="1" lang="ja-JP" altLang="en-US"/>
+          </a:p>
+        </p:txBody>
+      </p:sp>
+      <p:sp>
+        <p:nvSpPr>
+          <p:cNvPr id="15" name="Rectangle 14">
+            <a:extLst>
+              <a:ext uri="{FF2B5EF4-FFF2-40B4-BE49-F238E27FC236}">
+                <a16:creationId xmlns:a16="http://schemas.microsoft.com/office/drawing/2014/main" id="{2329DA31-3A5E-5F5D-53BD-42FFADC2EC25}"/>
+              </a:ext>
+            </a:extLst>
+          </p:cNvPr>
+          <p:cNvSpPr/>
+          <p:nvPr/>
+        </p:nvSpPr>
+        <p:spPr>
+          <a:xfrm>
+            <a:off x="1114425" y="662182"/>
+            <a:ext cx="2447925" cy="1068960"/>
+          </a:xfrm>
+          <a:prstGeom prst="rect">
+            <a:avLst/>
+          </a:prstGeom>
+          <a:noFill/>
+        </p:spPr>
+        <p:style>
+          <a:lnRef idx="2">
+            <a:schemeClr val="accent1">
+              <a:shade val="15000"/>
+            </a:schemeClr>
+          </a:lnRef>
+          <a:fillRef idx="1">
+            <a:schemeClr val="accent1"/>
+          </a:fillRef>
+          <a:effectRef idx="0">
+            <a:schemeClr val="accent1"/>
+          </a:effectRef>
+          <a:fontRef idx="minor">
+            <a:schemeClr val="lt1"/>
+          </a:fontRef>
+        </p:style>
+        <p:txBody>
+          <a:bodyPr rtlCol="0" anchor="ctr"/>
+          <a:lstStyle/>
+          <a:p>
+            <a:pPr algn="ctr"/>
+            <a:r>
+              <a:rPr kumimoji="1" lang="ja-JP" altLang="en-US" dirty="0">
+                <a:solidFill>
+                  <a:schemeClr val="tx1"/>
+                </a:solidFill>
+              </a:rPr>
+              <a:t>ここに波形</a:t>
+            </a:r>
+          </a:p>
+        </p:txBody>
+      </p:sp>
+      <p:sp>
+        <p:nvSpPr>
+          <p:cNvPr id="16" name="TextBox 15">
+            <a:extLst>
+              <a:ext uri="{FF2B5EF4-FFF2-40B4-BE49-F238E27FC236}">
+                <a16:creationId xmlns:a16="http://schemas.microsoft.com/office/drawing/2014/main" id="{1FA9BD3F-C70A-3617-F027-BD784931170E}"/>
+              </a:ext>
+            </a:extLst>
+          </p:cNvPr>
+          <p:cNvSpPr txBox="1"/>
+          <p:nvPr/>
+        </p:nvSpPr>
+        <p:spPr>
+          <a:xfrm>
+            <a:off x="1005839" y="1723208"/>
+            <a:ext cx="2624328" cy="307777"/>
+          </a:xfrm>
+          <a:prstGeom prst="rect">
+            <a:avLst/>
+          </a:prstGeom>
+          <a:noFill/>
+        </p:spPr>
+        <p:txBody>
+          <a:bodyPr wrap="square" rtlCol="0">
+            <a:spAutoFit/>
+          </a:bodyPr>
+          <a:lstStyle/>
+          <a:p>
+            <a:r>
+              <a:rPr lang="ja-JP" altLang="en-US" sz="1400" dirty="0"/>
+              <a:t>ファイル名：</a:t>
+            </a:r>
+            <a:endParaRPr kumimoji="1" lang="ja-JP" altLang="en-US" sz="1400" dirty="0"/>
+          </a:p>
+        </p:txBody>
+      </p:sp>
+      <p:sp>
+        <p:nvSpPr>
+          <p:cNvPr id="18" name="Rectangle: Beveled 17">
+            <a:extLst>
+              <a:ext uri="{FF2B5EF4-FFF2-40B4-BE49-F238E27FC236}">
+                <a16:creationId xmlns:a16="http://schemas.microsoft.com/office/drawing/2014/main" id="{089BA9BF-46B2-544B-ACB3-48E1CBDC8EA6}"/>
+              </a:ext>
+            </a:extLst>
+          </p:cNvPr>
+          <p:cNvSpPr/>
+          <p:nvPr/>
+        </p:nvSpPr>
+        <p:spPr>
+          <a:xfrm>
+            <a:off x="1114425" y="1984851"/>
+            <a:ext cx="752475" cy="307777"/>
+          </a:xfrm>
+          <a:prstGeom prst="bevel">
+            <a:avLst/>
+          </a:prstGeom>
+        </p:spPr>
+        <p:style>
+          <a:lnRef idx="2">
+            <a:schemeClr val="accent3">
+              <a:shade val="15000"/>
+            </a:schemeClr>
+          </a:lnRef>
+          <a:fillRef idx="1">
+            <a:schemeClr val="accent3"/>
+          </a:fillRef>
+          <a:effectRef idx="0">
+            <a:schemeClr val="accent3"/>
+          </a:effectRef>
+          <a:fontRef idx="minor">
+            <a:schemeClr val="lt1"/>
+          </a:fontRef>
+        </p:style>
+        <p:txBody>
+          <a:bodyPr rtlCol="0" anchor="ctr"/>
+          <a:lstStyle/>
+          <a:p>
+            <a:pPr algn="ctr"/>
+            <a:r>
+              <a:rPr kumimoji="1" lang="ja-JP" altLang="en-US" sz="1600" dirty="0"/>
+              <a:t>保存</a:t>
+            </a:r>
+          </a:p>
+        </p:txBody>
+      </p:sp>
+      <p:sp>
+        <p:nvSpPr>
+          <p:cNvPr id="19" name="Rectangle: Beveled 18">
+            <a:extLst>
+              <a:ext uri="{FF2B5EF4-FFF2-40B4-BE49-F238E27FC236}">
+                <a16:creationId xmlns:a16="http://schemas.microsoft.com/office/drawing/2014/main" id="{0E1525CC-4552-2FD0-4A8D-6CA12C33CB5F}"/>
+              </a:ext>
+            </a:extLst>
+          </p:cNvPr>
+          <p:cNvSpPr/>
+          <p:nvPr/>
+        </p:nvSpPr>
+        <p:spPr>
+          <a:xfrm>
+            <a:off x="1975487" y="1984851"/>
+            <a:ext cx="1586864" cy="307777"/>
+          </a:xfrm>
+          <a:prstGeom prst="bevel">
+            <a:avLst/>
+          </a:prstGeom>
+        </p:spPr>
+        <p:style>
+          <a:lnRef idx="2">
+            <a:schemeClr val="accent3">
+              <a:shade val="15000"/>
+            </a:schemeClr>
+          </a:lnRef>
+          <a:fillRef idx="1">
+            <a:schemeClr val="accent3"/>
+          </a:fillRef>
+          <a:effectRef idx="0">
+            <a:schemeClr val="accent3"/>
+          </a:effectRef>
+          <a:fontRef idx="minor">
+            <a:schemeClr val="lt1"/>
+          </a:fontRef>
+        </p:style>
+        <p:txBody>
+          <a:bodyPr rtlCol="0" anchor="ctr"/>
+          <a:lstStyle/>
+          <a:p>
+            <a:pPr algn="ctr"/>
+            <a:r>
+              <a:rPr kumimoji="1" lang="ja-JP" altLang="en-US" sz="1100" dirty="0"/>
+              <a:t>録音した音声を確認</a:t>
+            </a:r>
+          </a:p>
+        </p:txBody>
+      </p:sp>
+      <p:sp>
+        <p:nvSpPr>
+          <p:cNvPr id="20" name="Isosceles Triangle 19">
+            <a:extLst>
+              <a:ext uri="{FF2B5EF4-FFF2-40B4-BE49-F238E27FC236}">
+                <a16:creationId xmlns:a16="http://schemas.microsoft.com/office/drawing/2014/main" id="{D1B25746-4558-05F5-0170-23FBAB617B56}"/>
+              </a:ext>
+            </a:extLst>
+          </p:cNvPr>
+          <p:cNvSpPr/>
+          <p:nvPr/>
+        </p:nvSpPr>
+        <p:spPr>
+          <a:xfrm rot="5400000">
+            <a:off x="1231493" y="2636912"/>
+            <a:ext cx="245331" cy="217653"/>
+          </a:xfrm>
+          <a:prstGeom prst="triangle">
+            <a:avLst/>
+          </a:prstGeom>
+        </p:spPr>
+        <p:style>
+          <a:lnRef idx="2">
+            <a:schemeClr val="accent2">
+              <a:shade val="15000"/>
+            </a:schemeClr>
+          </a:lnRef>
+          <a:fillRef idx="1">
+            <a:schemeClr val="accent2"/>
+          </a:fillRef>
+          <a:effectRef idx="0">
+            <a:schemeClr val="accent2"/>
+          </a:effectRef>
+          <a:fontRef idx="minor">
+            <a:schemeClr val="lt1"/>
+          </a:fontRef>
+        </p:style>
+        <p:txBody>
+          <a:bodyPr rtlCol="0" anchor="ctr"/>
+          <a:lstStyle/>
+          <a:p>
+            <a:pPr algn="ctr"/>
+            <a:endParaRPr kumimoji="1" lang="ja-JP" altLang="en-US"/>
+          </a:p>
+        </p:txBody>
+      </p:sp>
+      <p:sp>
+        <p:nvSpPr>
+          <p:cNvPr id="21" name="Isosceles Triangle 20">
+            <a:extLst>
+              <a:ext uri="{FF2B5EF4-FFF2-40B4-BE49-F238E27FC236}">
+                <a16:creationId xmlns:a16="http://schemas.microsoft.com/office/drawing/2014/main" id="{3258F98A-A185-5EEB-C4F1-01E37A294A5F}"/>
+              </a:ext>
+            </a:extLst>
+          </p:cNvPr>
+          <p:cNvSpPr/>
+          <p:nvPr/>
+        </p:nvSpPr>
+        <p:spPr>
+          <a:xfrm rot="16200000">
+            <a:off x="3031718" y="2636912"/>
+            <a:ext cx="245331" cy="217653"/>
+          </a:xfrm>
+          <a:prstGeom prst="triangle">
+            <a:avLst/>
+          </a:prstGeom>
+        </p:spPr>
+        <p:style>
+          <a:lnRef idx="1">
+            <a:schemeClr val="dk1"/>
+          </a:lnRef>
+          <a:fillRef idx="2">
+            <a:schemeClr val="dk1"/>
+          </a:fillRef>
+          <a:effectRef idx="1">
+            <a:schemeClr val="dk1"/>
+          </a:effectRef>
+          <a:fontRef idx="minor">
+            <a:schemeClr val="dk1"/>
+          </a:fontRef>
+        </p:style>
+        <p:txBody>
+          <a:bodyPr rtlCol="0" anchor="ctr"/>
+          <a:lstStyle/>
+          <a:p>
+            <a:pPr algn="ctr"/>
+            <a:endParaRPr kumimoji="1" lang="ja-JP" altLang="en-US"/>
+          </a:p>
+        </p:txBody>
+      </p:sp>
+      <p:sp>
+        <p:nvSpPr>
+          <p:cNvPr id="22" name="Arc 21">
+            <a:extLst>
+              <a:ext uri="{FF2B5EF4-FFF2-40B4-BE49-F238E27FC236}">
+                <a16:creationId xmlns:a16="http://schemas.microsoft.com/office/drawing/2014/main" id="{F83158DF-845E-F1B5-52E2-CFF1D7637250}"/>
+              </a:ext>
+            </a:extLst>
+          </p:cNvPr>
+          <p:cNvSpPr/>
+          <p:nvPr/>
+        </p:nvSpPr>
+        <p:spPr>
+          <a:xfrm rot="19084917">
+            <a:off x="1276161" y="4801446"/>
+            <a:ext cx="1722496" cy="1722496"/>
+          </a:xfrm>
+          <a:prstGeom prst="arc">
+            <a:avLst>
+              <a:gd name="adj1" fmla="val 17155046"/>
+              <a:gd name="adj2" fmla="val 20321333"/>
+            </a:avLst>
+          </a:prstGeom>
+          <a:ln>
+            <a:headEnd type="arrow" w="med" len="med"/>
+            <a:tailEnd type="arrow" w="med" len="med"/>
+          </a:ln>
+        </p:spPr>
+        <p:style>
+          <a:lnRef idx="2">
+            <a:schemeClr val="dk1"/>
+          </a:lnRef>
+          <a:fillRef idx="0">
+            <a:schemeClr val="dk1"/>
+          </a:fillRef>
+          <a:effectRef idx="1">
+            <a:schemeClr val="dk1"/>
+          </a:effectRef>
+          <a:fontRef idx="minor">
+            <a:schemeClr val="tx1"/>
+          </a:fontRef>
+        </p:style>
+        <p:txBody>
+          <a:bodyPr rtlCol="0" anchor="ctr"/>
+          <a:lstStyle/>
+          <a:p>
+            <a:pPr algn="ctr"/>
+            <a:endParaRPr kumimoji="1" lang="ja-JP" altLang="en-US"/>
+          </a:p>
+        </p:txBody>
+      </p:sp>
+      <p:sp>
+        <p:nvSpPr>
+          <p:cNvPr id="23" name="TextBox 22">
+            <a:extLst>
+              <a:ext uri="{FF2B5EF4-FFF2-40B4-BE49-F238E27FC236}">
+                <a16:creationId xmlns:a16="http://schemas.microsoft.com/office/drawing/2014/main" id="{10B960A2-8462-7272-AF22-B6FB1C89332E}"/>
+              </a:ext>
+            </a:extLst>
+          </p:cNvPr>
+          <p:cNvSpPr txBox="1"/>
+          <p:nvPr/>
+        </p:nvSpPr>
+        <p:spPr>
+          <a:xfrm>
+            <a:off x="1522412" y="5821298"/>
+            <a:ext cx="3803969" cy="954107"/>
+          </a:xfrm>
+          <a:prstGeom prst="rect">
+            <a:avLst/>
+          </a:prstGeom>
+          <a:noFill/>
+        </p:spPr>
+        <p:txBody>
+          <a:bodyPr wrap="square" rtlCol="0">
+            <a:spAutoFit/>
+          </a:bodyPr>
+          <a:lstStyle/>
+          <a:p>
+            <a:r>
+              <a:rPr kumimoji="1" lang="en-US" altLang="ja-JP" sz="2800" dirty="0"/>
+              <a:t>90</a:t>
+            </a:r>
+            <a:r>
+              <a:rPr kumimoji="1" lang="ja-JP" altLang="en-US" sz="2800" dirty="0"/>
+              <a:t> </a:t>
+            </a:r>
+            <a:r>
+              <a:rPr kumimoji="1" lang="en-US" altLang="ja-JP" sz="2800" dirty="0"/>
+              <a:t>BPM</a:t>
+            </a:r>
+          </a:p>
+          <a:p>
+            <a:r>
+              <a:rPr kumimoji="1" lang="ja-JP" altLang="en-US" sz="2800" dirty="0"/>
+              <a:t>（数値入力も可能に）</a:t>
+            </a:r>
+          </a:p>
+        </p:txBody>
+      </p:sp>
+      <p:sp>
+        <p:nvSpPr>
+          <p:cNvPr id="24" name="Oval 23">
+            <a:extLst>
+              <a:ext uri="{FF2B5EF4-FFF2-40B4-BE49-F238E27FC236}">
+                <a16:creationId xmlns:a16="http://schemas.microsoft.com/office/drawing/2014/main" id="{CFEF82E4-2AE7-3197-7D9D-79730B153C31}"/>
+              </a:ext>
+            </a:extLst>
+          </p:cNvPr>
+          <p:cNvSpPr/>
+          <p:nvPr/>
+        </p:nvSpPr>
+        <p:spPr>
+          <a:xfrm>
+            <a:off x="949540" y="5821298"/>
+            <a:ext cx="404618" cy="404618"/>
+          </a:xfrm>
+          <a:prstGeom prst="ellipse">
+            <a:avLst/>
+          </a:prstGeom>
+        </p:spPr>
+        <p:style>
+          <a:lnRef idx="2">
+            <a:schemeClr val="dk1"/>
+          </a:lnRef>
+          <a:fillRef idx="1">
+            <a:schemeClr val="lt1"/>
+          </a:fillRef>
+          <a:effectRef idx="0">
+            <a:schemeClr val="dk1"/>
+          </a:effectRef>
+          <a:fontRef idx="minor">
+            <a:schemeClr val="dk1"/>
+          </a:fontRef>
+        </p:style>
+        <p:txBody>
+          <a:bodyPr rtlCol="0" anchor="ctr"/>
+          <a:lstStyle/>
+          <a:p>
+            <a:pPr algn="ctr"/>
+            <a:r>
+              <a:rPr kumimoji="1" lang="ja-JP" altLang="en-US" dirty="0"/>
+              <a:t>ー</a:t>
+            </a:r>
+          </a:p>
+        </p:txBody>
+      </p:sp>
+      <p:sp>
+        <p:nvSpPr>
+          <p:cNvPr id="25" name="Oval 24">
+            <a:extLst>
+              <a:ext uri="{FF2B5EF4-FFF2-40B4-BE49-F238E27FC236}">
+                <a16:creationId xmlns:a16="http://schemas.microsoft.com/office/drawing/2014/main" id="{E7C26FC4-4E72-C4DA-D2BD-4EC5803CACA0}"/>
+              </a:ext>
+            </a:extLst>
+          </p:cNvPr>
+          <p:cNvSpPr/>
+          <p:nvPr/>
+        </p:nvSpPr>
+        <p:spPr>
+          <a:xfrm>
+            <a:off x="3171164" y="5821298"/>
+            <a:ext cx="404618" cy="404618"/>
+          </a:xfrm>
+          <a:prstGeom prst="ellipse">
+            <a:avLst/>
+          </a:prstGeom>
+        </p:spPr>
+        <p:style>
+          <a:lnRef idx="2">
+            <a:schemeClr val="dk1"/>
+          </a:lnRef>
+          <a:fillRef idx="1">
+            <a:schemeClr val="lt1"/>
+          </a:fillRef>
+          <a:effectRef idx="0">
+            <a:schemeClr val="dk1"/>
+          </a:effectRef>
+          <a:fontRef idx="minor">
+            <a:schemeClr val="dk1"/>
+          </a:fontRef>
+        </p:style>
+        <p:txBody>
+          <a:bodyPr rtlCol="0" anchor="ctr"/>
+          <a:lstStyle/>
+          <a:p>
+            <a:pPr algn="ctr"/>
+            <a:r>
+              <a:rPr lang="en-US" altLang="ja-JP" dirty="0"/>
+              <a:t>+</a:t>
+            </a:r>
+            <a:endParaRPr kumimoji="1" lang="ja-JP" altLang="en-US" dirty="0"/>
+          </a:p>
+        </p:txBody>
+      </p:sp>
+      <p:sp>
+        <p:nvSpPr>
+          <p:cNvPr id="26" name="TextBox 25">
+            <a:extLst>
+              <a:ext uri="{FF2B5EF4-FFF2-40B4-BE49-F238E27FC236}">
+                <a16:creationId xmlns:a16="http://schemas.microsoft.com/office/drawing/2014/main" id="{48A0BA08-5D14-C2BC-3152-5AB34A1D341C}"/>
+              </a:ext>
+            </a:extLst>
+          </p:cNvPr>
+          <p:cNvSpPr txBox="1"/>
+          <p:nvPr/>
+        </p:nvSpPr>
+        <p:spPr>
+          <a:xfrm>
+            <a:off x="690085" y="7214151"/>
+            <a:ext cx="771560" cy="523220"/>
+          </a:xfrm>
+          <a:prstGeom prst="rect">
+            <a:avLst/>
+          </a:prstGeom>
+          <a:noFill/>
+        </p:spPr>
+        <p:txBody>
+          <a:bodyPr wrap="square" rtlCol="0">
+            <a:spAutoFit/>
+          </a:bodyPr>
+          <a:lstStyle/>
+          <a:p>
+            <a:r>
+              <a:rPr lang="en-US" altLang="ja-JP" sz="2800" dirty="0"/>
+              <a:t>4/4</a:t>
+            </a:r>
+            <a:endParaRPr kumimoji="1" lang="ja-JP" altLang="en-US" sz="2800" dirty="0"/>
+          </a:p>
+        </p:txBody>
+      </p:sp>
+      <p:sp>
+        <p:nvSpPr>
+          <p:cNvPr id="27" name="Oval 26">
+            <a:extLst>
+              <a:ext uri="{FF2B5EF4-FFF2-40B4-BE49-F238E27FC236}">
+                <a16:creationId xmlns:a16="http://schemas.microsoft.com/office/drawing/2014/main" id="{3DB40D25-EA18-96B3-B1CD-8C9FE8DCFF40}"/>
+              </a:ext>
+            </a:extLst>
+          </p:cNvPr>
+          <p:cNvSpPr/>
+          <p:nvPr/>
+        </p:nvSpPr>
+        <p:spPr>
+          <a:xfrm>
+            <a:off x="1080609" y="6925814"/>
+            <a:ext cx="105855" cy="105855"/>
+          </a:xfrm>
+          <a:prstGeom prst="ellipse">
+            <a:avLst/>
+          </a:prstGeom>
+        </p:spPr>
+        <p:style>
+          <a:lnRef idx="2">
+            <a:schemeClr val="dk1">
+              <a:shade val="15000"/>
+            </a:schemeClr>
+          </a:lnRef>
+          <a:fillRef idx="1">
+            <a:schemeClr val="dk1"/>
+          </a:fillRef>
+          <a:effectRef idx="0">
+            <a:schemeClr val="dk1"/>
+          </a:effectRef>
+          <a:fontRef idx="minor">
+            <a:schemeClr val="lt1"/>
+          </a:fontRef>
+        </p:style>
+        <p:txBody>
+          <a:bodyPr rtlCol="0" anchor="ctr"/>
+          <a:lstStyle/>
+          <a:p>
+            <a:pPr algn="ctr"/>
+            <a:endParaRPr kumimoji="1" lang="ja-JP" altLang="en-US" dirty="0"/>
+          </a:p>
+        </p:txBody>
+      </p:sp>
+      <p:sp>
+        <p:nvSpPr>
+          <p:cNvPr id="28" name="Oval 27">
+            <a:extLst>
+              <a:ext uri="{FF2B5EF4-FFF2-40B4-BE49-F238E27FC236}">
+                <a16:creationId xmlns:a16="http://schemas.microsoft.com/office/drawing/2014/main" id="{9EDFE395-4F3A-99DE-6243-E3D9407D5142}"/>
+              </a:ext>
+            </a:extLst>
+          </p:cNvPr>
+          <p:cNvSpPr/>
+          <p:nvPr/>
+        </p:nvSpPr>
+        <p:spPr>
+          <a:xfrm>
+            <a:off x="1755231" y="6925814"/>
+            <a:ext cx="105855" cy="105855"/>
+          </a:xfrm>
+          <a:prstGeom prst="ellipse">
+            <a:avLst/>
+          </a:prstGeom>
+        </p:spPr>
+        <p:style>
+          <a:lnRef idx="2">
+            <a:schemeClr val="dk1"/>
+          </a:lnRef>
+          <a:fillRef idx="1">
+            <a:schemeClr val="lt1"/>
+          </a:fillRef>
+          <a:effectRef idx="0">
+            <a:schemeClr val="dk1"/>
+          </a:effectRef>
+          <a:fontRef idx="minor">
+            <a:schemeClr val="dk1"/>
+          </a:fontRef>
+        </p:style>
+        <p:txBody>
+          <a:bodyPr rtlCol="0" anchor="ctr"/>
+          <a:lstStyle/>
+          <a:p>
+            <a:pPr algn="ctr"/>
+            <a:endParaRPr kumimoji="1" lang="ja-JP" altLang="en-US" dirty="0"/>
+          </a:p>
+        </p:txBody>
+      </p:sp>
+      <p:sp>
+        <p:nvSpPr>
+          <p:cNvPr id="29" name="Oval 28">
+            <a:extLst>
+              <a:ext uri="{FF2B5EF4-FFF2-40B4-BE49-F238E27FC236}">
+                <a16:creationId xmlns:a16="http://schemas.microsoft.com/office/drawing/2014/main" id="{E5D8FC6A-44A8-47D4-56FC-F6AF31A70486}"/>
+              </a:ext>
+            </a:extLst>
+          </p:cNvPr>
+          <p:cNvSpPr/>
+          <p:nvPr/>
+        </p:nvSpPr>
+        <p:spPr>
+          <a:xfrm>
+            <a:off x="2512149" y="6925814"/>
+            <a:ext cx="105855" cy="105855"/>
+          </a:xfrm>
+          <a:prstGeom prst="ellipse">
+            <a:avLst/>
+          </a:prstGeom>
+        </p:spPr>
+        <p:style>
+          <a:lnRef idx="2">
+            <a:schemeClr val="dk1"/>
+          </a:lnRef>
+          <a:fillRef idx="1">
+            <a:schemeClr val="lt1"/>
+          </a:fillRef>
+          <a:effectRef idx="0">
+            <a:schemeClr val="dk1"/>
+          </a:effectRef>
+          <a:fontRef idx="minor">
+            <a:schemeClr val="dk1"/>
+          </a:fontRef>
+        </p:style>
+        <p:txBody>
+          <a:bodyPr rtlCol="0" anchor="ctr"/>
+          <a:lstStyle/>
+          <a:p>
+            <a:pPr algn="ctr"/>
+            <a:endParaRPr kumimoji="1" lang="ja-JP" altLang="en-US" dirty="0"/>
+          </a:p>
+        </p:txBody>
+      </p:sp>
+      <p:sp>
+        <p:nvSpPr>
+          <p:cNvPr id="30" name="Oval 29">
+            <a:extLst>
+              <a:ext uri="{FF2B5EF4-FFF2-40B4-BE49-F238E27FC236}">
+                <a16:creationId xmlns:a16="http://schemas.microsoft.com/office/drawing/2014/main" id="{7279DE3B-1F0A-2DCF-B62B-423E81FD8564}"/>
+              </a:ext>
+            </a:extLst>
+          </p:cNvPr>
+          <p:cNvSpPr/>
+          <p:nvPr/>
+        </p:nvSpPr>
+        <p:spPr>
+          <a:xfrm>
+            <a:off x="3253807" y="6925814"/>
+            <a:ext cx="105855" cy="105855"/>
+          </a:xfrm>
+          <a:prstGeom prst="ellipse">
+            <a:avLst/>
+          </a:prstGeom>
+        </p:spPr>
+        <p:style>
+          <a:lnRef idx="2">
+            <a:schemeClr val="dk1"/>
+          </a:lnRef>
+          <a:fillRef idx="1">
+            <a:schemeClr val="lt1"/>
+          </a:fillRef>
+          <a:effectRef idx="0">
+            <a:schemeClr val="dk1"/>
+          </a:effectRef>
+          <a:fontRef idx="minor">
+            <a:schemeClr val="dk1"/>
+          </a:fontRef>
+        </p:style>
+        <p:txBody>
+          <a:bodyPr rtlCol="0" anchor="ctr"/>
+          <a:lstStyle/>
+          <a:p>
+            <a:pPr algn="ctr"/>
+            <a:endParaRPr kumimoji="1" lang="ja-JP" altLang="en-US" dirty="0"/>
+          </a:p>
+        </p:txBody>
+      </p:sp>
+      <p:sp>
+        <p:nvSpPr>
+          <p:cNvPr id="31" name="TextBox 30">
+            <a:extLst>
+              <a:ext uri="{FF2B5EF4-FFF2-40B4-BE49-F238E27FC236}">
+                <a16:creationId xmlns:a16="http://schemas.microsoft.com/office/drawing/2014/main" id="{1ED56647-4CE9-788C-FCFB-00C4AEA27ED7}"/>
+              </a:ext>
+            </a:extLst>
+          </p:cNvPr>
+          <p:cNvSpPr txBox="1"/>
+          <p:nvPr/>
+        </p:nvSpPr>
+        <p:spPr>
+          <a:xfrm>
+            <a:off x="1591909" y="7214151"/>
+            <a:ext cx="5805587" cy="523220"/>
+          </a:xfrm>
+          <a:prstGeom prst="rect">
+            <a:avLst/>
+          </a:prstGeom>
+          <a:noFill/>
+        </p:spPr>
+        <p:txBody>
+          <a:bodyPr wrap="square" rtlCol="0">
+            <a:spAutoFit/>
+          </a:bodyPr>
+          <a:lstStyle/>
+          <a:p>
+            <a:r>
+              <a:rPr lang="en-US" altLang="ja-JP" sz="2800" dirty="0"/>
+              <a:t>4</a:t>
+            </a:r>
+            <a:r>
+              <a:rPr lang="ja-JP" altLang="en-US" sz="2800" dirty="0"/>
+              <a:t>分音符（三連符もできたらいい）</a:t>
+            </a:r>
+            <a:endParaRPr kumimoji="1" lang="ja-JP" altLang="en-US" sz="2800" dirty="0"/>
+          </a:p>
+        </p:txBody>
+      </p:sp>
     </p:spTree>
     <p:extLst>
       <p:ext uri="{BB962C8B-B14F-4D97-AF65-F5344CB8AC3E}">

</xml_diff>